<commit_message>
fix(resources): correct the privacy Act, add the five-minute cut
The deck's privacy slides cited PPIPA and HRIPA (NSW public sector). The
session is being run in a non-government school, which sits under the
federal Privacy Act and the Australian Privacy Principles instead —
allied-health reports are health information under that Act. Swapped the
primary framing and kept PPIPA/HRIPA as the stated contrast so a reader
from the public system isn't left applying the wrong instrument.

The download card's caveat said the deck cites PPIPA, which is no longer
true — rewritten to match, and to tell presenters to put a real privacy
contact on the recovery slide.

Also adds a six-slide, five-minute cut alongside the full 18-slide
session: title, the metaphor in one frame, the red lines, C.O.R.E.,
recovery, closer. Both decks now offered.

Co-Authored-By: Claude Opus 5 <noreply@anthropic.com>
</commit_message>
<xml_diff>
--- a/mait-mvp/frontend/public/genius-baby-forklift-pd-deck.pptx
+++ b/mait-mvp/frontend/public/genius-baby-forklift-pd-deck.pptx
@@ -694,7 +694,7 @@
           <a:lstStyle/>
           <a:p>
             <a:r>
-              <a:t>Before you present: confirm your current departmental AI-use policy and approved-tool list, and check whether your school is being steered to a department-provided assistant rather than Copilot — that guidance moves, so verify it rather than trusting this slide. The legal point is the one to land: NSW public schools sit under PPIPA, not the federal Australian Privacy Principles, and allied-health reports pick up HRIPA on top. Non-government schools are the reverse — federal Privacy Act and the APPs. If your audience is mixed, say that out loud.</a:t>
+              <a:t>Before you present: confirm the school's current AI-use policy and approved-tool list — that guidance moves, so verify it rather than trusting this slide. The legal point to land is that non-government schools sit under the federal Privacy Act and the Australian Privacy Principles. NSW public schools are the other way round — PPIPA, plus HRIPA for allied-health reports — so if anyone in the room has come from the public system, say that out loud so they don't apply the wrong instrument. Allied-health reports are health information either way, which is the highest bar of all. Don't improvise beyond this: if you're asked something you can't answer, say you'll check with the privacy lead.</a:t>
             </a:r>
           </a:p>
         </p:txBody>
@@ -3712,7 +3712,7 @@
                 <a:ea typeface="Calibri" pitchFamily="34" charset="-122"/>
                 <a:cs typeface="Calibri" pitchFamily="34" charset="-120"/>
               </a:rPr>
-              <a:t>Enterprise protection governs where your data travels. It does not grant permission to put student information into it. In a NSW public school that permission is governed by PPIPA, by HRIPA for anything originating with a psychologist, OT, speech pathologist or paediatrician, and by your school's own AI-use policy. None of that changed when Copilot arrived.</a:t>
+              <a:t>Enterprise protection governs where your data travels. It does not grant permission to put student information into it. As a non-government school we sit under the federal Privacy Act and the Australian Privacy Principles — and anything from a psychologist, OT, speech pathologist or paediatrician is health information, which carries a higher bar again. None of that changed when Copilot arrived.</a:t>
             </a:r>
             <a:endParaRPr lang="en-US" sz="1350" dirty="0"/>
           </a:p>

</xml_diff>